<commit_message>
I add My Presentation
</commit_message>
<xml_diff>
--- a/reports/Bank_Campaign_Presentation_F.pptx
+++ b/reports/Bank_Campaign_Presentation_F.pptx
@@ -131,6 +131,15 @@
 </p:presentation>
 </file>
 
+<file path=ppt/revisionInfo.xml><?xml version="1.0" encoding="utf-8"?>
+<p1510:revInfo xmlns:a="http://schemas.openxmlformats.org/drawingml/2006/main" xmlns:r="http://schemas.openxmlformats.org/officeDocument/2006/relationships" xmlns:p1510="http://schemas.microsoft.com/office/powerpoint/2015/10/main">
+  <p1510:revLst>
+    <p1510:client id="{5FBD43B8-F967-C647-DA7F-924F4A3E3077}" v="11" dt="2026-03-07T01:42:48.420"/>
+    <p1510:client id="{9393F183-4D39-47D2-82BB-DACCD78F7DBC}" v="71" dt="2026-03-07T01:46:00.429"/>
+  </p1510:revLst>
+</p1510:revInfo>
+</file>
+
 <file path=ppt/diagrams/colors1.xml><?xml version="1.0" encoding="utf-8"?>
 <dgm:colorsDef xmlns:dgm="http://schemas.openxmlformats.org/drawingml/2006/diagram" xmlns:a="http://schemas.openxmlformats.org/drawingml/2006/main" uniqueId="urn:microsoft.com/office/officeart/2005/8/colors/accent1_2">
   <dgm:title val=""/>
@@ -3902,21 +3911,21 @@
         <a:lstStyle/>
         <a:p>
           <a:r>
-            <a:rPr lang="en-US" sz="1600" b="1" dirty="0"/>
+            <a:rPr lang="en-US" sz="1600" b="1"/>
             <a:t>Dataset</a:t>
           </a:r>
           <a:r>
-            <a:rPr lang="en-US" sz="1600" dirty="0"/>
+            <a:rPr lang="en-US" sz="1600"/>
             <a:t>:</a:t>
           </a:r>
         </a:p>
         <a:p>
           <a:r>
-            <a:rPr lang="en-US" sz="1600" dirty="0"/>
+            <a:rPr lang="en-US" sz="1600"/>
             <a:t> </a:t>
           </a:r>
           <a:r>
-            <a:rPr lang="en-US" sz="1400" dirty="0"/>
+            <a:rPr lang="en-US" sz="1400"/>
             <a:t>Direct marketing campaigns from a Portuguese bank</a:t>
           </a:r>
         </a:p>
@@ -3952,21 +3961,21 @@
         <a:lstStyle/>
         <a:p>
           <a:r>
-            <a:rPr lang="en-US" sz="1600" b="1" dirty="0"/>
+            <a:rPr lang="en-US" sz="1600" b="1"/>
             <a:t>Goal</a:t>
           </a:r>
           <a:r>
-            <a:rPr lang="en-US" sz="1600" dirty="0"/>
+            <a:rPr lang="en-US" sz="1600"/>
             <a:t>:</a:t>
           </a:r>
         </a:p>
         <a:p>
           <a:r>
-            <a:rPr lang="en-US" sz="1600" dirty="0"/>
+            <a:rPr lang="en-US" sz="1600"/>
             <a:t> </a:t>
           </a:r>
           <a:r>
-            <a:rPr lang="en-US" sz="1400" dirty="0"/>
+            <a:rPr lang="en-US" sz="1400"/>
             <a:t>Predict whether a client will subscribe (y: yes/no)</a:t>
           </a:r>
         </a:p>
@@ -4002,17 +4011,17 @@
         <a:lstStyle/>
         <a:p>
           <a:r>
-            <a:rPr lang="en-US" sz="1600" b="1" dirty="0"/>
+            <a:rPr lang="en-US" sz="1600" b="1"/>
             <a:t>Importance</a:t>
           </a:r>
           <a:r>
-            <a:rPr lang="en-US" sz="1600" dirty="0"/>
+            <a:rPr lang="en-US" sz="1600"/>
             <a:t>: </a:t>
           </a:r>
         </a:p>
         <a:p>
           <a:r>
-            <a:rPr lang="en-US" sz="1400" dirty="0"/>
+            <a:rPr lang="en-US" sz="1400"/>
             <a:t>Target high-probability clients, reduce cost, increase ROI</a:t>
           </a:r>
         </a:p>
@@ -4180,8 +4189,13 @@
         <a:bodyPr/>
         <a:lstStyle/>
         <a:p>
+          <a:pPr>
+            <a:lnSpc>
+              <a:spcPct val="100000"/>
+            </a:lnSpc>
+          </a:pPr>
           <a:r>
-            <a:rPr lang="en-US" dirty="0"/>
+            <a:rPr lang="en-US"/>
             <a:t>Models used for prediction:</a:t>
           </a:r>
         </a:p>
@@ -4216,6 +4230,11 @@
         <a:bodyPr/>
         <a:lstStyle/>
         <a:p>
+          <a:pPr>
+            <a:lnSpc>
+              <a:spcPct val="100000"/>
+            </a:lnSpc>
+          </a:pPr>
           <a:r>
             <a:rPr lang="en-US"/>
             <a:t>• Logistic Regression (baseline)</a:t>
@@ -4252,6 +4271,11 @@
         <a:bodyPr/>
         <a:lstStyle/>
         <a:p>
+          <a:pPr>
+            <a:lnSpc>
+              <a:spcPct val="100000"/>
+            </a:lnSpc>
+          </a:pPr>
           <a:r>
             <a:rPr lang="en-US"/>
             <a:t>• Decision Tree (simple, interpretable)</a:t>
@@ -4288,6 +4312,11 @@
         <a:bodyPr/>
         <a:lstStyle/>
         <a:p>
+          <a:pPr>
+            <a:lnSpc>
+              <a:spcPct val="100000"/>
+            </a:lnSpc>
+          </a:pPr>
           <a:r>
             <a:rPr lang="en-US"/>
             <a:t>• Random Forest (ensemble, reduces overfitting)</a:t>
@@ -4324,22 +4353,19 @@
         <a:bodyPr/>
         <a:lstStyle/>
         <a:p>
+          <a:pPr>
+            <a:lnSpc>
+              <a:spcPct val="100000"/>
+            </a:lnSpc>
+          </a:pPr>
           <a:r>
-            <a:rPr lang="en-US" dirty="0"/>
-            <a:t>• </a:t>
-          </a:r>
-          <a:r>
-            <a:rPr lang="en-US" dirty="0" err="1"/>
-            <a:t>XGBoost</a:t>
-          </a:r>
-          <a:r>
-            <a:rPr lang="en-US" dirty="0"/>
-            <a:t> (gradient boosting, best accuracy &amp; recall balance)</a:t>
+            <a:rPr lang="en-US"/>
+            <a:t>• XGBoost (gradient boosting, best accuracy &amp; recall balance)</a:t>
           </a:r>
         </a:p>
       </dgm:t>
     </dgm:pt>
-    <dgm:pt modelId="{35BF2584-826D-4D4D-9892-4AE3EED5A6F6}" type="parTrans" cxnId="{789B88FA-05C1-45C3-9FBE-4B2F312661C7}">
+    <dgm:pt modelId="{9EC276D9-63A8-41B9-95A4-8752C9E3B59B}" type="sibTrans" cxnId="{789B88FA-05C1-45C3-9FBE-4B2F312661C7}">
       <dgm:prSet/>
       <dgm:spPr/>
       <dgm:t>
@@ -4350,7 +4376,7 @@
         </a:p>
       </dgm:t>
     </dgm:pt>
-    <dgm:pt modelId="{9EC276D9-63A8-41B9-95A4-8752C9E3B59B}" type="sibTrans" cxnId="{789B88FA-05C1-45C3-9FBE-4B2F312661C7}">
+    <dgm:pt modelId="{35BF2584-826D-4D4D-9892-4AE3EED5A6F6}" type="parTrans" cxnId="{789B88FA-05C1-45C3-9FBE-4B2F312661C7}">
       <dgm:prSet/>
       <dgm:spPr/>
       <dgm:t>
@@ -4925,7 +4951,7 @@
         <a:bodyPr/>
         <a:lstStyle/>
         <a:p>
-          <a:endParaRPr lang="en-US" dirty="0"/>
+          <a:endParaRPr lang="en-US"/>
         </a:p>
       </dgm:t>
     </dgm:pt>
@@ -5296,10 +5322,10 @@
         <a:lstStyle/>
         <a:p>
           <a:r>
-            <a:rPr lang="en-US" b="1" dirty="0"/>
+            <a:rPr lang="en-US" b="1"/>
             <a:t>2. Strategic Timing (When to Call)</a:t>
           </a:r>
-          <a:endParaRPr lang="en-US" dirty="0"/>
+          <a:endParaRPr lang="en-US"/>
         </a:p>
       </dgm:t>
     </dgm:pt>
@@ -5665,20 +5691,16 @@
             <a:buNone/>
           </a:pPr>
           <a:r>
-            <a:rPr lang="en-CA" b="1" dirty="0">
+            <a:rPr lang="en-CA" b="1">
               <a:solidFill>
-                <a:schemeClr val="bg2">
-                  <a:lumMod val="75000"/>
-                </a:schemeClr>
+                <a:schemeClr val="bg1"/>
               </a:solidFill>
             </a:rPr>
             <a:t>Marketing Strategy:</a:t>
           </a:r>
-          <a:endParaRPr lang="en-CA" dirty="0">
+          <a:endParaRPr lang="en-CA">
             <a:solidFill>
-              <a:schemeClr val="bg2">
-                <a:lumMod val="75000"/>
-              </a:schemeClr>
+              <a:schemeClr val="bg1"/>
             </a:solidFill>
           </a:endParaRPr>
         </a:p>
@@ -5718,7 +5740,7 @@
             <a:buChar char="•"/>
           </a:pPr>
           <a:r>
-            <a:rPr lang="en-US" dirty="0"/>
+            <a:rPr lang="en-US"/>
             <a:t>Focus calls on high-propensity clients</a:t>
           </a:r>
         </a:p>
@@ -5837,20 +5859,16 @@
             <a:buNone/>
           </a:pPr>
           <a:r>
-            <a:rPr lang="en-CA" b="1" dirty="0">
+            <a:rPr lang="en-CA" b="1">
               <a:solidFill>
-                <a:schemeClr val="bg2">
-                  <a:lumMod val="75000"/>
-                </a:schemeClr>
+                <a:schemeClr val="bg1"/>
               </a:solidFill>
             </a:rPr>
             <a:t>Timing:</a:t>
           </a:r>
-          <a:endParaRPr lang="en-CA" dirty="0">
+          <a:endParaRPr lang="en-CA">
             <a:solidFill>
-              <a:schemeClr val="bg2">
-                <a:lumMod val="75000"/>
-              </a:schemeClr>
+              <a:schemeClr val="bg1"/>
             </a:solidFill>
           </a:endParaRPr>
         </a:p>
@@ -5929,20 +5947,16 @@
             <a:buNone/>
           </a:pPr>
           <a:r>
-            <a:rPr lang="en-CA" b="1" dirty="0">
+            <a:rPr lang="en-CA" b="1">
               <a:solidFill>
-                <a:schemeClr val="bg2">
-                  <a:lumMod val="75000"/>
-                </a:schemeClr>
+                <a:schemeClr val="bg1"/>
               </a:solidFill>
             </a:rPr>
             <a:t>Compliance &amp; Explainability:</a:t>
           </a:r>
-          <a:endParaRPr lang="en-CA" dirty="0">
+          <a:endParaRPr lang="en-CA">
             <a:solidFill>
-              <a:schemeClr val="bg2">
-                <a:lumMod val="75000"/>
-              </a:schemeClr>
+              <a:schemeClr val="bg1"/>
             </a:solidFill>
           </a:endParaRPr>
         </a:p>
@@ -6061,20 +6075,18 @@
             <a:buNone/>
           </a:pPr>
           <a:r>
-            <a:rPr lang="en-CA" b="1" dirty="0">
+            <a:rPr lang="en-CA" b="1">
               <a:solidFill>
-                <a:schemeClr val="bg2">
-                  <a:lumMod val="75000"/>
-                </a:schemeClr>
+                <a:schemeClr val="bg1"/>
               </a:solidFill>
             </a:rPr>
-            <a:t>Impact</a:t>
+            <a:t>Impact:</a:t>
           </a:r>
-          <a:r>
-            <a:rPr lang="en-CA" b="1" dirty="0"/>
-            <a:t>:</a:t>
-          </a:r>
-          <a:endParaRPr lang="en-CA" dirty="0"/>
+          <a:endParaRPr lang="en-CA">
+            <a:solidFill>
+              <a:schemeClr val="bg1"/>
+            </a:solidFill>
+          </a:endParaRPr>
         </a:p>
       </dgm:t>
     </dgm:pt>
@@ -6417,8 +6429,8 @@
       </dsp:nvSpPr>
       <dsp:spPr>
         <a:xfrm>
-          <a:off x="0" y="787390"/>
-          <a:ext cx="2055020" cy="1304938"/>
+          <a:off x="0" y="736035"/>
+          <a:ext cx="2000710" cy="1270451"/>
         </a:xfrm>
         <a:prstGeom prst="roundRect">
           <a:avLst>
@@ -6468,8 +6480,8 @@
       </dsp:nvSpPr>
       <dsp:spPr>
         <a:xfrm>
-          <a:off x="228335" y="1004309"/>
-          <a:ext cx="2055020" cy="1304938"/>
+          <a:off x="222301" y="947221"/>
+          <a:ext cx="2000710" cy="1270451"/>
         </a:xfrm>
         <a:prstGeom prst="roundRect">
           <a:avLst>
@@ -6529,11 +6541,11 @@
             <a:buNone/>
           </a:pPr>
           <a:r>
-            <a:rPr lang="en-US" sz="1600" b="1" kern="1200" dirty="0"/>
+            <a:rPr lang="en-US" sz="1600" b="1" kern="1200"/>
             <a:t>Dataset</a:t>
           </a:r>
           <a:r>
-            <a:rPr lang="en-US" sz="1600" kern="1200" dirty="0"/>
+            <a:rPr lang="en-US" sz="1600" kern="1200"/>
             <a:t>:</a:t>
           </a:r>
         </a:p>
@@ -6551,18 +6563,18 @@
             <a:buNone/>
           </a:pPr>
           <a:r>
-            <a:rPr lang="en-US" sz="1600" kern="1200" dirty="0"/>
+            <a:rPr lang="en-US" sz="1600" kern="1200"/>
             <a:t> </a:t>
           </a:r>
           <a:r>
-            <a:rPr lang="en-US" sz="1400" kern="1200" dirty="0"/>
+            <a:rPr lang="en-US" sz="1400" kern="1200"/>
             <a:t>Direct marketing campaigns from a Portuguese bank</a:t>
           </a:r>
         </a:p>
       </dsp:txBody>
       <dsp:txXfrm>
-        <a:off x="266555" y="1042529"/>
-        <a:ext cx="1978580" cy="1228498"/>
+        <a:off x="259511" y="984431"/>
+        <a:ext cx="1926290" cy="1196031"/>
       </dsp:txXfrm>
     </dsp:sp>
     <dsp:sp modelId="{600B2D1A-CF93-4DD8-86B3-62B43238B145}">
@@ -6572,8 +6584,8 @@
       </dsp:nvSpPr>
       <dsp:spPr>
         <a:xfrm>
-          <a:off x="2511691" y="787390"/>
-          <a:ext cx="2055020" cy="1304938"/>
+          <a:off x="2445313" y="736035"/>
+          <a:ext cx="2000710" cy="1270451"/>
         </a:xfrm>
         <a:prstGeom prst="roundRect">
           <a:avLst>
@@ -6623,8 +6635,8 @@
       </dsp:nvSpPr>
       <dsp:spPr>
         <a:xfrm>
-          <a:off x="2740027" y="1004309"/>
-          <a:ext cx="2055020" cy="1304938"/>
+          <a:off x="2667614" y="947221"/>
+          <a:ext cx="2000710" cy="1270451"/>
         </a:xfrm>
         <a:prstGeom prst="roundRect">
           <a:avLst>
@@ -6684,11 +6696,11 @@
             <a:buNone/>
           </a:pPr>
           <a:r>
-            <a:rPr lang="en-US" sz="1600" b="1" kern="1200" dirty="0"/>
+            <a:rPr lang="en-US" sz="1600" b="1" kern="1200"/>
             <a:t>Goal</a:t>
           </a:r>
           <a:r>
-            <a:rPr lang="en-US" sz="1600" kern="1200" dirty="0"/>
+            <a:rPr lang="en-US" sz="1600" kern="1200"/>
             <a:t>:</a:t>
           </a:r>
         </a:p>
@@ -6706,18 +6718,18 @@
             <a:buNone/>
           </a:pPr>
           <a:r>
-            <a:rPr lang="en-US" sz="1600" kern="1200" dirty="0"/>
+            <a:rPr lang="en-US" sz="1600" kern="1200"/>
             <a:t> </a:t>
           </a:r>
           <a:r>
-            <a:rPr lang="en-US" sz="1400" kern="1200" dirty="0"/>
+            <a:rPr lang="en-US" sz="1400" kern="1200"/>
             <a:t>Predict whether a client will subscribe (y: yes/no)</a:t>
           </a:r>
         </a:p>
       </dsp:txBody>
       <dsp:txXfrm>
-        <a:off x="2778247" y="1042529"/>
-        <a:ext cx="1978580" cy="1228498"/>
+        <a:off x="2704824" y="984431"/>
+        <a:ext cx="1926290" cy="1196031"/>
       </dsp:txXfrm>
     </dsp:sp>
     <dsp:sp modelId="{A934565B-5C92-4433-B788-876CE1172E81}">
@@ -6727,8 +6739,8 @@
       </dsp:nvSpPr>
       <dsp:spPr>
         <a:xfrm>
-          <a:off x="5023383" y="787390"/>
-          <a:ext cx="2055020" cy="1304938"/>
+          <a:off x="4890626" y="736035"/>
+          <a:ext cx="2000710" cy="1270451"/>
         </a:xfrm>
         <a:prstGeom prst="roundRect">
           <a:avLst>
@@ -6778,8 +6790,8 @@
       </dsp:nvSpPr>
       <dsp:spPr>
         <a:xfrm>
-          <a:off x="5251719" y="1004309"/>
-          <a:ext cx="2055020" cy="1304938"/>
+          <a:off x="5112927" y="947221"/>
+          <a:ext cx="2000710" cy="1270451"/>
         </a:xfrm>
         <a:prstGeom prst="roundRect">
           <a:avLst>
@@ -6839,11 +6851,11 @@
             <a:buNone/>
           </a:pPr>
           <a:r>
-            <a:rPr lang="en-US" sz="1600" b="1" kern="1200" dirty="0"/>
+            <a:rPr lang="en-US" sz="1600" b="1" kern="1200"/>
             <a:t>Importance</a:t>
           </a:r>
           <a:r>
-            <a:rPr lang="en-US" sz="1600" kern="1200" dirty="0"/>
+            <a:rPr lang="en-US" sz="1600" kern="1200"/>
             <a:t>: </a:t>
           </a:r>
         </a:p>
@@ -6861,14 +6873,14 @@
             <a:buNone/>
           </a:pPr>
           <a:r>
-            <a:rPr lang="en-US" sz="1400" kern="1200" dirty="0"/>
+            <a:rPr lang="en-US" sz="1400" kern="1200"/>
             <a:t>Target high-probability clients, reduce cost, increase ROI</a:t>
           </a:r>
         </a:p>
       </dsp:txBody>
       <dsp:txXfrm>
-        <a:off x="5289939" y="1042529"/>
-        <a:ext cx="1978580" cy="1228498"/>
+        <a:off x="5150137" y="984431"/>
+        <a:ext cx="1926290" cy="1196031"/>
       </dsp:txXfrm>
     </dsp:sp>
   </dsp:spTree>
@@ -7012,7 +7024,7 @@
         <a:p>
           <a:pPr marL="0" lvl="0" indent="0" algn="l" defTabSz="844550">
             <a:lnSpc>
-              <a:spcPct val="90000"/>
+              <a:spcPct val="100000"/>
             </a:lnSpc>
             <a:spcBef>
               <a:spcPct val="0"/>
@@ -7023,7 +7035,7 @@
             <a:buNone/>
           </a:pPr>
           <a:r>
-            <a:rPr lang="en-US" sz="1900" kern="1200" dirty="0"/>
+            <a:rPr lang="en-US" sz="1900" kern="1200"/>
             <a:t>Models used for prediction:</a:t>
           </a:r>
         </a:p>
@@ -7162,7 +7174,7 @@
         <a:p>
           <a:pPr marL="0" lvl="0" indent="0" algn="l" defTabSz="844550">
             <a:lnSpc>
-              <a:spcPct val="90000"/>
+              <a:spcPct val="100000"/>
             </a:lnSpc>
             <a:spcBef>
               <a:spcPct val="0"/>
@@ -7312,7 +7324,7 @@
         <a:p>
           <a:pPr marL="0" lvl="0" indent="0" algn="l" defTabSz="844550">
             <a:lnSpc>
-              <a:spcPct val="90000"/>
+              <a:spcPct val="100000"/>
             </a:lnSpc>
             <a:spcBef>
               <a:spcPct val="0"/>
@@ -7462,7 +7474,7 @@
         <a:p>
           <a:pPr marL="0" lvl="0" indent="0" algn="l" defTabSz="844550">
             <a:lnSpc>
-              <a:spcPct val="90000"/>
+              <a:spcPct val="100000"/>
             </a:lnSpc>
             <a:spcBef>
               <a:spcPct val="0"/>
@@ -7612,7 +7624,7 @@
         <a:p>
           <a:pPr marL="0" lvl="0" indent="0" algn="l" defTabSz="844550">
             <a:lnSpc>
-              <a:spcPct val="90000"/>
+              <a:spcPct val="100000"/>
             </a:lnSpc>
             <a:spcBef>
               <a:spcPct val="0"/>
@@ -7623,16 +7635,8 @@
             <a:buNone/>
           </a:pPr>
           <a:r>
-            <a:rPr lang="en-US" sz="1900" kern="1200" dirty="0"/>
-            <a:t>• </a:t>
-          </a:r>
-          <a:r>
-            <a:rPr lang="en-US" sz="1900" kern="1200" dirty="0" err="1"/>
-            <a:t>XGBoost</a:t>
-          </a:r>
-          <a:r>
-            <a:rPr lang="en-US" sz="1900" kern="1200" dirty="0"/>
-            <a:t> (gradient boosting, best accuracy &amp; recall balance)</a:t>
+            <a:rPr lang="en-US" sz="1900" kern="1200"/>
+            <a:t>• XGBoost (gradient boosting, best accuracy &amp; recall balance)</a:t>
           </a:r>
         </a:p>
       </dsp:txBody>
@@ -8409,7 +8413,7 @@
             </a:spcAft>
             <a:buNone/>
           </a:pPr>
-          <a:endParaRPr lang="en-US" sz="1100" kern="1200" dirty="0"/>
+          <a:endParaRPr lang="en-US" sz="1100" kern="1200"/>
         </a:p>
       </dsp:txBody>
       <dsp:txXfrm>
@@ -9205,10 +9209,10 @@
             <a:buNone/>
           </a:pPr>
           <a:r>
-            <a:rPr lang="en-US" sz="900" b="1" kern="1200" dirty="0"/>
+            <a:rPr lang="en-US" sz="900" b="1" kern="1200"/>
             <a:t>2. Strategic Timing (When to Call)</a:t>
           </a:r>
-          <a:endParaRPr lang="en-US" sz="900" kern="1200" dirty="0"/>
+          <a:endParaRPr lang="en-US" sz="900" kern="1200"/>
         </a:p>
       </dsp:txBody>
       <dsp:txXfrm>
@@ -9637,20 +9641,16 @@
             <a:buNone/>
           </a:pPr>
           <a:r>
-            <a:rPr lang="en-CA" sz="1400" b="1" kern="1200" dirty="0">
+            <a:rPr lang="en-CA" sz="1400" b="1" kern="1200">
               <a:solidFill>
-                <a:schemeClr val="bg2">
-                  <a:lumMod val="75000"/>
-                </a:schemeClr>
+                <a:schemeClr val="bg1"/>
               </a:solidFill>
             </a:rPr>
             <a:t>Marketing Strategy:</a:t>
           </a:r>
-          <a:endParaRPr lang="en-CA" sz="1400" kern="1200" dirty="0">
+          <a:endParaRPr lang="en-CA" sz="1400" kern="1200">
             <a:solidFill>
-              <a:schemeClr val="bg2">
-                <a:lumMod val="75000"/>
-              </a:schemeClr>
+              <a:schemeClr val="bg1"/>
             </a:solidFill>
           </a:endParaRPr>
         </a:p>
@@ -9756,7 +9756,7 @@
             <a:buNone/>
           </a:pPr>
           <a:r>
-            <a:rPr lang="en-US" sz="1400" kern="1200" dirty="0"/>
+            <a:rPr lang="en-US" sz="1400" kern="1200"/>
             <a:t>Focus calls on high-propensity clients</a:t>
           </a:r>
         </a:p>
@@ -10073,20 +10073,16 @@
             <a:buNone/>
           </a:pPr>
           <a:r>
-            <a:rPr lang="en-CA" sz="1400" b="1" kern="1200" dirty="0">
+            <a:rPr lang="en-CA" sz="1400" b="1" kern="1200">
               <a:solidFill>
-                <a:schemeClr val="bg2">
-                  <a:lumMod val="75000"/>
-                </a:schemeClr>
+                <a:schemeClr val="bg1"/>
               </a:solidFill>
             </a:rPr>
             <a:t>Timing:</a:t>
           </a:r>
-          <a:endParaRPr lang="en-CA" sz="1400" kern="1200" dirty="0">
+          <a:endParaRPr lang="en-CA" sz="1400" kern="1200">
             <a:solidFill>
-              <a:schemeClr val="bg2">
-                <a:lumMod val="75000"/>
-              </a:schemeClr>
+              <a:schemeClr val="bg1"/>
             </a:solidFill>
           </a:endParaRPr>
         </a:p>
@@ -10297,20 +10293,16 @@
             <a:buNone/>
           </a:pPr>
           <a:r>
-            <a:rPr lang="en-CA" sz="1400" b="1" kern="1200" dirty="0">
+            <a:rPr lang="en-CA" sz="1400" b="1" kern="1200">
               <a:solidFill>
-                <a:schemeClr val="bg2">
-                  <a:lumMod val="75000"/>
-                </a:schemeClr>
+                <a:schemeClr val="bg1"/>
               </a:solidFill>
             </a:rPr>
             <a:t>Compliance &amp; Explainability:</a:t>
           </a:r>
-          <a:endParaRPr lang="en-CA" sz="1400" kern="1200" dirty="0">
+          <a:endParaRPr lang="en-CA" sz="1400" kern="1200">
             <a:solidFill>
-              <a:schemeClr val="bg2">
-                <a:lumMod val="75000"/>
-              </a:schemeClr>
+              <a:schemeClr val="bg1"/>
             </a:solidFill>
           </a:endParaRPr>
         </a:p>
@@ -10627,20 +10619,18 @@
             <a:buNone/>
           </a:pPr>
           <a:r>
-            <a:rPr lang="en-CA" sz="1400" b="1" kern="1200" dirty="0">
+            <a:rPr lang="en-CA" sz="1400" b="1" kern="1200">
               <a:solidFill>
-                <a:schemeClr val="bg2">
-                  <a:lumMod val="75000"/>
-                </a:schemeClr>
+                <a:schemeClr val="bg1"/>
               </a:solidFill>
             </a:rPr>
-            <a:t>Impact</a:t>
+            <a:t>Impact:</a:t>
           </a:r>
-          <a:r>
-            <a:rPr lang="en-CA" sz="1400" b="1" kern="1200" dirty="0"/>
-            <a:t>:</a:t>
-          </a:r>
-          <a:endParaRPr lang="en-CA" sz="1400" kern="1200" dirty="0"/>
+          <a:endParaRPr lang="en-CA" sz="1400" kern="1200">
+            <a:solidFill>
+              <a:schemeClr val="bg1"/>
+            </a:solidFill>
+          </a:endParaRPr>
         </a:p>
       </dsp:txBody>
       <dsp:txXfrm>
@@ -18169,7 +18159,7 @@
           <a:p>
             <a:fld id="{B68C591A-7041-41BA-9B02-4F7E4896C2D4}" type="datetimeFigureOut">
               <a:rPr lang="en-CA" smtClean="0"/>
-              <a:t>2026-03-05</a:t>
+              <a:t>2026-03-06</a:t>
             </a:fld>
             <a:endParaRPr lang="en-CA"/>
           </a:p>
@@ -18481,7 +18471,7 @@
           <a:bodyPr/>
           <a:lstStyle/>
           <a:p>
-            <a:endParaRPr lang="en-CA" dirty="0"/>
+            <a:endParaRPr lang="en-CA"/>
           </a:p>
         </p:txBody>
       </p:sp>
@@ -18512,6 +18502,90 @@
     <p:extLst>
       <p:ext uri="{BB962C8B-B14F-4D97-AF65-F5344CB8AC3E}">
         <p14:creationId xmlns:p14="http://schemas.microsoft.com/office/powerpoint/2010/main" val="2546467380"/>
+      </p:ext>
+    </p:extLst>
+  </p:cSld>
+  <p:clrMapOvr>
+    <a:masterClrMapping/>
+  </p:clrMapOvr>
+</p:notes>
+</file>
+
+<file path=ppt/notesSlides/notesSlide2.xml><?xml version="1.0" encoding="utf-8"?>
+<p:notes xmlns:a="http://schemas.openxmlformats.org/drawingml/2006/main" xmlns:r="http://schemas.openxmlformats.org/officeDocument/2006/relationships" xmlns:p="http://schemas.openxmlformats.org/presentationml/2006/main">
+  <p:cSld>
+    <p:spTree>
+      <p:nvGrpSpPr>
+        <p:cNvPr id="1" name=""/>
+        <p:cNvGrpSpPr/>
+        <p:nvPr/>
+      </p:nvGrpSpPr>
+      <p:grpSpPr>
+        <a:xfrm>
+          <a:off x="0" y="0"/>
+          <a:ext cx="0" cy="0"/>
+          <a:chOff x="0" y="0"/>
+          <a:chExt cx="0" cy="0"/>
+        </a:xfrm>
+      </p:grpSpPr>
+      <p:sp>
+        <p:nvSpPr>
+          <p:cNvPr id="2" name="Slide Image Placeholder 1"/>
+          <p:cNvSpPr>
+            <a:spLocks noGrp="1" noRot="1" noChangeAspect="1"/>
+          </p:cNvSpPr>
+          <p:nvPr>
+            <p:ph type="sldImg"/>
+          </p:nvPr>
+        </p:nvSpPr>
+        <p:spPr/>
+      </p:sp>
+      <p:sp>
+        <p:nvSpPr>
+          <p:cNvPr id="3" name="Notes Placeholder 2"/>
+          <p:cNvSpPr>
+            <a:spLocks noGrp="1"/>
+          </p:cNvSpPr>
+          <p:nvPr>
+            <p:ph type="body" idx="1"/>
+          </p:nvPr>
+        </p:nvSpPr>
+        <p:spPr/>
+        <p:txBody>
+          <a:bodyPr/>
+          <a:lstStyle/>
+          <a:p>
+            <a:endParaRPr lang="en-CA"/>
+          </a:p>
+        </p:txBody>
+      </p:sp>
+      <p:sp>
+        <p:nvSpPr>
+          <p:cNvPr id="4" name="Slide Number Placeholder 3"/>
+          <p:cNvSpPr>
+            <a:spLocks noGrp="1"/>
+          </p:cNvSpPr>
+          <p:nvPr>
+            <p:ph type="sldNum" sz="quarter" idx="5"/>
+          </p:nvPr>
+        </p:nvSpPr>
+        <p:spPr/>
+        <p:txBody>
+          <a:bodyPr/>
+          <a:lstStyle/>
+          <a:p>
+            <a:fld id="{1434B633-36C6-4534-A0AF-A59E08D2AE1D}" type="slidenum">
+              <a:rPr lang="en-CA" smtClean="0"/>
+              <a:t>4</a:t>
+            </a:fld>
+            <a:endParaRPr lang="en-CA"/>
+          </a:p>
+        </p:txBody>
+      </p:sp>
+    </p:spTree>
+    <p:extLst>
+      <p:ext uri="{BB962C8B-B14F-4D97-AF65-F5344CB8AC3E}">
+        <p14:creationId xmlns:p14="http://schemas.microsoft.com/office/powerpoint/2010/main" val="785488201"/>
       </p:ext>
     </p:extLst>
   </p:cSld>
@@ -18707,7 +18781,6 @@
               <a:rPr lang="en-US"/>
               <a:t>Click to edit Master title style</a:t>
             </a:r>
-            <a:endParaRPr lang="en-US" dirty="0"/>
           </a:p>
         </p:txBody>
       </p:sp>
@@ -18774,7 +18847,6 @@
               <a:rPr lang="en-US"/>
               <a:t>Click to edit Master subtitle style</a:t>
             </a:r>
-            <a:endParaRPr lang="en-US" dirty="0"/>
           </a:p>
         </p:txBody>
       </p:sp>
@@ -19070,7 +19142,6 @@
               <a:rPr lang="en-US"/>
               <a:t>Click to edit Master title style</a:t>
             </a:r>
-            <a:endParaRPr lang="en-US" dirty="0"/>
           </a:p>
         </p:txBody>
       </p:sp>
@@ -19146,7 +19217,6 @@
               <a:rPr lang="en-US"/>
               <a:t>Click icon to add picture</a:t>
             </a:r>
-            <a:endParaRPr lang="en-US" dirty="0"/>
           </a:p>
         </p:txBody>
       </p:sp>
@@ -19495,7 +19565,6 @@
               <a:rPr lang="en-US"/>
               <a:t>Click to edit Master title style</a:t>
             </a:r>
-            <a:endParaRPr lang="en-US" dirty="0"/>
           </a:p>
         </p:txBody>
       </p:sp>
@@ -19844,7 +19913,6 @@
               <a:rPr lang="en-US"/>
               <a:t>Click to edit Master title style</a:t>
             </a:r>
-            <a:endParaRPr lang="en-US" dirty="0"/>
           </a:p>
         </p:txBody>
       </p:sp>
@@ -20157,7 +20225,7 @@
           <a:p>
             <a:pPr lvl="0"/>
             <a:r>
-              <a:rPr lang="en-US" sz="7200" dirty="0">
+              <a:rPr lang="en-US" sz="7200">
                 <a:solidFill>
                   <a:schemeClr val="tx1"/>
                 </a:solidFill>
@@ -20273,7 +20341,7 @@
           <a:p>
             <a:pPr lvl="0" algn="r"/>
             <a:r>
-              <a:rPr lang="en-US" sz="7200" dirty="0">
+              <a:rPr lang="en-US" sz="7200">
                 <a:solidFill>
                   <a:schemeClr val="tx1"/>
                 </a:solidFill>
@@ -20494,7 +20562,6 @@
               <a:rPr lang="en-US"/>
               <a:t>Click to edit Master title style</a:t>
             </a:r>
-            <a:endParaRPr lang="en-US" dirty="0"/>
           </a:p>
         </p:txBody>
       </p:sp>
@@ -20839,7 +20906,6 @@
               <a:rPr lang="en-US"/>
               <a:t>Click to edit Master title style</a:t>
             </a:r>
-            <a:endParaRPr lang="en-US" dirty="0"/>
           </a:p>
         </p:txBody>
       </p:sp>
@@ -21528,7 +21594,6 @@
               <a:rPr lang="en-US"/>
               <a:t>Click to edit Master title style</a:t>
             </a:r>
-            <a:endParaRPr lang="en-US" dirty="0"/>
           </a:p>
         </p:txBody>
       </p:sp>
@@ -21678,7 +21743,6 @@
               <a:rPr lang="en-US"/>
               <a:t>Click icon to add picture</a:t>
             </a:r>
-            <a:endParaRPr lang="en-US" dirty="0"/>
           </a:p>
         </p:txBody>
       </p:sp>
@@ -21895,7 +21959,6 @@
               <a:rPr lang="en-US"/>
               <a:t>Click icon to add picture</a:t>
             </a:r>
-            <a:endParaRPr lang="en-US" dirty="0"/>
           </a:p>
         </p:txBody>
       </p:sp>
@@ -22112,7 +22175,6 @@
               <a:rPr lang="en-US"/>
               <a:t>Click icon to add picture</a:t>
             </a:r>
-            <a:endParaRPr lang="en-US" dirty="0"/>
           </a:p>
         </p:txBody>
       </p:sp>
@@ -22458,7 +22520,6 @@
               <a:rPr lang="en-US"/>
               <a:t>Click to edit Master title style</a:t>
             </a:r>
-            <a:endParaRPr lang="en-US" dirty="0"/>
           </a:p>
         </p:txBody>
       </p:sp>
@@ -22510,7 +22571,6 @@
               <a:rPr lang="en-US"/>
               <a:t>Fifth level</a:t>
             </a:r>
-            <a:endParaRPr lang="en-US" dirty="0"/>
           </a:p>
         </p:txBody>
       </p:sp>
@@ -22727,7 +22787,6 @@
               <a:rPr lang="en-US"/>
               <a:t>Click to edit Master title style</a:t>
             </a:r>
-            <a:endParaRPr lang="en-US" dirty="0"/>
           </a:p>
         </p:txBody>
       </p:sp>
@@ -22784,7 +22843,6 @@
               <a:rPr lang="en-US"/>
               <a:t>Fifth level</a:t>
             </a:r>
-            <a:endParaRPr lang="en-US" dirty="0"/>
           </a:p>
         </p:txBody>
       </p:sp>
@@ -23073,7 +23131,6 @@
               <a:rPr lang="en-US"/>
               <a:t>Click to edit Master title style</a:t>
             </a:r>
-            <a:endParaRPr lang="en-US" dirty="0"/>
           </a:p>
         </p:txBody>
       </p:sp>
@@ -23125,7 +23182,6 @@
               <a:rPr lang="en-US"/>
               <a:t>Fifth level</a:t>
             </a:r>
-            <a:endParaRPr lang="en-US" dirty="0"/>
           </a:p>
         </p:txBody>
       </p:sp>
@@ -23406,7 +23462,6 @@
               <a:rPr lang="en-US"/>
               <a:t>Click to edit Master title style</a:t>
             </a:r>
-            <a:endParaRPr lang="en-US" dirty="0"/>
           </a:p>
         </p:txBody>
       </p:sp>
@@ -23817,7 +23872,6 @@
               <a:rPr lang="en-US"/>
               <a:t>Click to edit Master title style</a:t>
             </a:r>
-            <a:endParaRPr lang="en-US" dirty="0"/>
           </a:p>
         </p:txBody>
       </p:sp>
@@ -23874,7 +23928,6 @@
               <a:rPr lang="en-US"/>
               <a:t>Fifth level</a:t>
             </a:r>
-            <a:endParaRPr lang="en-US" dirty="0"/>
           </a:p>
         </p:txBody>
       </p:sp>
@@ -23931,7 +23984,6 @@
               <a:rPr lang="en-US"/>
               <a:t>Fifth level</a:t>
             </a:r>
-            <a:endParaRPr lang="en-US" dirty="0"/>
           </a:p>
         </p:txBody>
       </p:sp>
@@ -24206,7 +24258,6 @@
               <a:rPr lang="en-US"/>
               <a:t>Click to edit Master title style</a:t>
             </a:r>
-            <a:endParaRPr lang="en-US" dirty="0"/>
           </a:p>
         </p:txBody>
       </p:sp>
@@ -24328,7 +24379,6 @@
               <a:rPr lang="en-US"/>
               <a:t>Fifth level</a:t>
             </a:r>
-            <a:endParaRPr lang="en-US" dirty="0"/>
           </a:p>
         </p:txBody>
       </p:sp>
@@ -24450,7 +24500,6 @@
               <a:rPr lang="en-US"/>
               <a:t>Fifth level</a:t>
             </a:r>
-            <a:endParaRPr lang="en-US" dirty="0"/>
           </a:p>
         </p:txBody>
       </p:sp>
@@ -24710,7 +24759,7 @@
             <a:bodyPr/>
             <a:lstStyle/>
             <a:p>
-              <a:endParaRPr lang="en-CA" dirty="0"/>
+              <a:endParaRPr lang="en-CA"/>
             </a:p>
           </p:txBody>
         </p:sp>
@@ -24734,7 +24783,6 @@
               <a:rPr lang="en-US"/>
               <a:t>Click to edit Master title style</a:t>
             </a:r>
-            <a:endParaRPr lang="en-US" dirty="0"/>
           </a:p>
         </p:txBody>
       </p:sp>
@@ -24792,19 +24840,25 @@
         </p:nvSpPr>
         <p:spPr>
           <a:xfrm>
-            <a:off x="7860756" y="5936188"/>
+            <a:off x="7921141" y="6118750"/>
             <a:ext cx="1157674" cy="597108"/>
           </a:xfrm>
         </p:spPr>
         <p:txBody>
           <a:bodyPr/>
-          <a:lstStyle/>
+          <a:lstStyle>
+            <a:lvl1pPr algn="r">
+              <a:defRPr sz="1500"/>
+            </a:lvl1pPr>
+          </a:lstStyle>
           <a:p>
+            <a:pPr algn="r"/>
             <a:fld id="{C1FF6DA9-008F-8B48-92A6-B652298478BF}" type="slidenum">
               <a:rPr lang="en-US" smtClean="0"/>
+              <a:pPr algn="r"/>
               <a:t>‹#›</a:t>
             </a:fld>
-            <a:endParaRPr lang="en-US" dirty="0"/>
+            <a:endParaRPr lang="en-US"/>
           </a:p>
         </p:txBody>
       </p:sp>
@@ -25182,7 +25236,6 @@
               <a:rPr lang="en-US"/>
               <a:t>Click to edit Master title style</a:t>
             </a:r>
-            <a:endParaRPr lang="en-US" dirty="0"/>
           </a:p>
         </p:txBody>
       </p:sp>
@@ -25239,7 +25292,6 @@
               <a:rPr lang="en-US"/>
               <a:t>Fifth level</a:t>
             </a:r>
-            <a:endParaRPr lang="en-US" dirty="0"/>
           </a:p>
         </p:txBody>
       </p:sp>
@@ -25585,7 +25637,6 @@
               <a:rPr lang="en-US"/>
               <a:t>Click to edit Master title style</a:t>
             </a:r>
-            <a:endParaRPr lang="en-US" dirty="0"/>
           </a:p>
         </p:txBody>
       </p:sp>
@@ -25661,7 +25712,6 @@
               <a:rPr lang="en-US"/>
               <a:t>Click icon to add picture</a:t>
             </a:r>
-            <a:endParaRPr lang="en-US" dirty="0"/>
           </a:p>
         </p:txBody>
       </p:sp>
@@ -25900,7 +25950,6 @@
               <a:rPr lang="en-US"/>
               <a:t>Click to edit Master title style</a:t>
             </a:r>
-            <a:endParaRPr lang="en-US" dirty="0"/>
           </a:p>
         </p:txBody>
       </p:sp>
@@ -25962,7 +26011,6 @@
               <a:rPr lang="en-US"/>
               <a:t>Fifth level</a:t>
             </a:r>
-            <a:endParaRPr lang="en-US" dirty="0"/>
           </a:p>
         </p:txBody>
       </p:sp>
@@ -26437,10 +26485,10 @@
           <a:lstStyle/>
           <a:p>
             <a:r>
-              <a:rPr lang="en-US" dirty="0"/>
+              <a:rPr lang="en-US"/>
               <a:t>Bank Marketing Project</a:t>
             </a:r>
-            <a:endParaRPr lang="en-CA" dirty="0"/>
+            <a:endParaRPr lang="en-CA"/>
           </a:p>
         </p:txBody>
       </p:sp>
@@ -26473,7 +26521,7 @@
           <a:lstStyle/>
           <a:p>
             <a:r>
-              <a:rPr lang="en-US" b="1" dirty="0">
+              <a:rPr lang="en-US" b="1">
                 <a:solidFill>
                   <a:schemeClr val="bg1"/>
                 </a:solidFill>
@@ -26481,14 +26529,14 @@
               <a:t> </a:t>
             </a:r>
             <a:r>
-              <a:rPr lang="en-US" sz="2000" b="1" dirty="0">
+              <a:rPr lang="en-US" sz="2000" b="1">
                 <a:solidFill>
                   <a:schemeClr val="bg1"/>
                 </a:solidFill>
               </a:rPr>
               <a:t>Predicting Term Deposit Subscriptions</a:t>
             </a:r>
-            <a:endParaRPr lang="en-CA" sz="2000" b="1" dirty="0">
+            <a:endParaRPr lang="en-CA" sz="2000" b="1">
               <a:solidFill>
                 <a:schemeClr val="bg1"/>
               </a:solidFill>
@@ -26518,10 +26566,10 @@
           <a:lstStyle/>
           <a:p>
             <a:fld id="{C1FF6DA9-008F-8B48-92A6-B652298478BF}" type="slidenum">
-              <a:rPr lang="en-US" smtClean="0"/>
+              <a:rPr lang="en-US" sz="2000" smtClean="0"/>
               <a:t>1</a:t>
             </a:fld>
-            <a:endParaRPr lang="en-US" dirty="0"/>
+            <a:endParaRPr lang="en-US" sz="2000"/>
           </a:p>
         </p:txBody>
       </p:sp>
@@ -26547,7 +26595,7 @@
         </p:blipFill>
         <p:spPr>
           <a:xfrm>
-            <a:off x="163285" y="2830286"/>
+            <a:off x="163285" y="3033476"/>
             <a:ext cx="8817429" cy="2902712"/>
           </a:xfrm>
           <a:prstGeom prst="rect">
@@ -26629,7 +26677,7 @@
           <a:lstStyle/>
           <a:p>
             <a:r>
-              <a:rPr sz="1600" b="1" dirty="0">
+              <a:rPr sz="1600" b="1">
                 <a:solidFill>
                   <a:schemeClr val="bg2">
                     <a:lumMod val="75000"/>
@@ -26639,21 +26687,18 @@
               <a:t>Question</a:t>
             </a:r>
             <a:r>
-              <a:rPr sz="1400" dirty="0"/>
+              <a:rPr sz="1400"/>
               <a:t>: </a:t>
             </a:r>
             <a:r>
-              <a:rPr sz="1400" b="1" dirty="0"/>
-              <a:t>How can we increase campaign efficiency and conversion while reducing cost?</a:t>
+              <a:rPr lang="en-US" sz="1400" b="1"/>
+              <a:t>How can we increase subscription rates to term deposits while reducing telemarketing costs?</a:t>
             </a:r>
-            <a:endParaRPr lang="en-CA" sz="1400" b="1" dirty="0"/>
-          </a:p>
-          <a:p>
-            <a:endParaRPr lang="en-CA" sz="1400" b="1" dirty="0"/>
+            <a:endParaRPr lang="en-CA" sz="1400" b="1"/>
           </a:p>
           <a:p>
             <a:r>
-              <a:rPr lang="en-CA" sz="1600" b="1" dirty="0">
+              <a:rPr lang="en-CA" sz="1600" b="1">
                 <a:solidFill>
                   <a:schemeClr val="bg2">
                     <a:lumMod val="75000"/>
@@ -26663,19 +26708,19 @@
               <a:t>Dataset</a:t>
             </a:r>
             <a:r>
-              <a:rPr lang="en-CA" sz="1600" dirty="0"/>
+              <a:rPr lang="en-CA" sz="1600"/>
               <a:t>: </a:t>
             </a:r>
             <a:r>
-              <a:rPr lang="en-CA" sz="1400" b="1" dirty="0"/>
+              <a:rPr lang="en-CA" sz="1400" b="1"/>
               <a:t>UCI Bank Marketing Dataset</a:t>
             </a:r>
           </a:p>
           <a:p>
-            <a:endParaRPr sz="1400" b="1" dirty="0"/>
+            <a:endParaRPr sz="1400" b="1"/>
           </a:p>
           <a:p>
-            <a:endParaRPr lang="en-CA" sz="1400" b="1" dirty="0">
+            <a:endParaRPr lang="en-CA" sz="1400" b="1">
               <a:solidFill>
                 <a:schemeClr val="bg2">
                   <a:lumMod val="75000"/>
@@ -26684,7 +26729,7 @@
             </a:endParaRPr>
           </a:p>
           <a:p>
-            <a:endParaRPr lang="en-CA" sz="1400" b="1" dirty="0">
+            <a:endParaRPr lang="en-CA" sz="1400" b="1">
               <a:solidFill>
                 <a:schemeClr val="bg2">
                   <a:lumMod val="75000"/>
@@ -26693,7 +26738,7 @@
             </a:endParaRPr>
           </a:p>
           <a:p>
-            <a:endParaRPr lang="en-US" sz="1400" b="1" dirty="0">
+            <a:endParaRPr lang="en-US" sz="1400" b="1">
               <a:solidFill>
                 <a:schemeClr val="bg2">
                   <a:lumMod val="75000"/>
@@ -26702,10 +26747,10 @@
             </a:endParaRPr>
           </a:p>
           <a:p>
-            <a:endParaRPr lang="en-US" sz="1400" b="1" dirty="0"/>
+            <a:endParaRPr lang="en-US" sz="1400" b="1"/>
           </a:p>
           <a:p>
-            <a:endParaRPr lang="en-US" sz="1400" b="1" dirty="0">
+            <a:endParaRPr lang="en-US" sz="1400" b="1">
               <a:solidFill>
                 <a:schemeClr val="bg2">
                   <a:lumMod val="75000"/>
@@ -26714,7 +26759,7 @@
             </a:endParaRPr>
           </a:p>
           <a:p>
-            <a:endParaRPr lang="en-US" sz="1400" b="1" dirty="0">
+            <a:endParaRPr lang="en-US" sz="1400" b="1">
               <a:solidFill>
                 <a:schemeClr val="bg2">
                   <a:lumMod val="75000"/>
@@ -26724,7 +26769,7 @@
           </a:p>
           <a:p>
             <a:r>
-              <a:rPr lang="en-US" sz="1400" b="1" dirty="0">
+              <a:rPr lang="en-US" sz="1400" b="1">
                 <a:solidFill>
                   <a:schemeClr val="bg2">
                     <a:lumMod val="75000"/>
@@ -26734,11 +26779,11 @@
               <a:t>Pre-campaign</a:t>
             </a:r>
             <a:r>
-              <a:rPr lang="en-US" sz="1400" b="1" dirty="0"/>
+              <a:rPr lang="en-US" sz="1400" b="1"/>
               <a:t> vs </a:t>
             </a:r>
             <a:r>
-              <a:rPr lang="en-US" sz="1400" b="1" dirty="0">
+              <a:rPr lang="en-US" sz="1400" b="1">
                 <a:solidFill>
                   <a:schemeClr val="bg2">
                     <a:lumMod val="75000"/>
@@ -26748,33 +26793,33 @@
               <a:t>Post-campaign</a:t>
             </a:r>
             <a:r>
-              <a:rPr lang="en-US" sz="1400" b="1" dirty="0"/>
+              <a:rPr lang="en-US" sz="1400" b="1"/>
               <a:t>:</a:t>
             </a:r>
-            <a:endParaRPr lang="en-US" sz="1400" dirty="0"/>
+            <a:endParaRPr lang="en-US" sz="1400"/>
           </a:p>
           <a:p>
             <a:r>
-              <a:rPr lang="en-US" sz="1400" b="1" dirty="0"/>
+              <a:rPr lang="en-US" sz="1400" b="1"/>
               <a:t>Pre-campaign:</a:t>
             </a:r>
             <a:r>
-              <a:rPr lang="en-US" sz="1400" dirty="0"/>
+              <a:rPr lang="en-US" sz="1400"/>
               <a:t> Known before calling → used for modeling</a:t>
             </a:r>
           </a:p>
           <a:p>
             <a:r>
-              <a:rPr lang="en-US" sz="1400" b="1" dirty="0"/>
+              <a:rPr lang="en-US" sz="1400" b="1"/>
               <a:t>Post-campaign:</a:t>
             </a:r>
             <a:r>
-              <a:rPr lang="en-US" sz="1400" dirty="0"/>
-              <a:t> Known after calling → removed to avoid leakage</a:t>
+              <a:rPr lang="en-US" sz="1400"/>
+              <a:t> Known after calling → ‘duration’removed to avoid leakage</a:t>
             </a:r>
           </a:p>
           <a:p>
-            <a:endParaRPr sz="1400" dirty="0"/>
+            <a:endParaRPr sz="1400"/>
           </a:p>
         </p:txBody>
       </p:sp>
@@ -26793,14 +26838,14 @@
           <p:nvPr>
             <p:extLst>
               <p:ext uri="{D42A27DB-BD31-4B8C-83A1-F6EECF244321}">
-                <p14:modId xmlns:p14="http://schemas.microsoft.com/office/powerpoint/2010/main" val="1578125561"/>
+                <p14:modId xmlns:p14="http://schemas.microsoft.com/office/powerpoint/2010/main" val="357984678"/>
               </p:ext>
             </p:extLst>
           </p:nvPr>
         </p:nvGraphicFramePr>
         <p:xfrm>
-          <a:off x="457201" y="4314039"/>
-          <a:ext cx="7306740" cy="3096638"/>
+          <a:off x="531639" y="4549381"/>
+          <a:ext cx="7113638" cy="2953708"/>
         </p:xfrm>
         <a:graphic>
           <a:graphicData uri="http://schemas.openxmlformats.org/drawingml/2006/diagram">
@@ -26823,13 +26868,13 @@
           <p:nvPr>
             <p:extLst>
               <p:ext uri="{D42A27DB-BD31-4B8C-83A1-F6EECF244321}">
-                <p14:modId xmlns:p14="http://schemas.microsoft.com/office/powerpoint/2010/main" val="1245082508"/>
+                <p14:modId xmlns:p14="http://schemas.microsoft.com/office/powerpoint/2010/main" val="3365649052"/>
               </p:ext>
             </p:extLst>
           </p:nvPr>
         </p:nvGraphicFramePr>
         <p:xfrm>
-          <a:off x="457198" y="2974287"/>
+          <a:off x="527957" y="2913060"/>
           <a:ext cx="4744410" cy="1339752"/>
         </p:xfrm>
         <a:graphic>
@@ -26861,7 +26906,7 @@
                     <a:lstStyle/>
                     <a:p>
                       <a:r>
-                        <a:rPr lang="en-CA" sz="1400" dirty="0"/>
+                        <a:rPr lang="en-CA" sz="1400"/>
                         <a:t>Categorical Features</a:t>
                       </a:r>
                     </a:p>
@@ -26874,7 +26919,7 @@
                     <a:lstStyle/>
                     <a:p>
                       <a:r>
-                        <a:rPr lang="en-CA" sz="1400" dirty="0"/>
+                        <a:rPr lang="en-CA" sz="1400"/>
                         <a:t>Numerical  Features</a:t>
                       </a:r>
                     </a:p>
@@ -26894,7 +26939,7 @@
                     <a:lstStyle/>
                     <a:p>
                       <a:r>
-                        <a:rPr lang="en-CA" sz="1400" dirty="0"/>
+                        <a:rPr lang="en-CA" sz="1400"/>
                         <a:t>Job</a:t>
                       </a:r>
                     </a:p>
@@ -26907,7 +26952,7 @@
                     <a:lstStyle/>
                     <a:p>
                       <a:r>
-                        <a:rPr lang="en-CA" sz="1400" dirty="0"/>
+                        <a:rPr lang="en-CA" sz="1400"/>
                         <a:t>Age</a:t>
                       </a:r>
                     </a:p>
@@ -26927,7 +26972,7 @@
                     <a:lstStyle/>
                     <a:p>
                       <a:r>
-                        <a:rPr lang="en-CA" sz="1400" dirty="0"/>
+                        <a:rPr lang="en-CA" sz="1400"/>
                         <a:t>Marital</a:t>
                       </a:r>
                     </a:p>
@@ -26940,7 +26985,7 @@
                     <a:lstStyle/>
                     <a:p>
                       <a:r>
-                        <a:rPr lang="en-CA" sz="1400" dirty="0"/>
+                        <a:rPr lang="en-CA" sz="1400"/>
                         <a:t>Campaign</a:t>
                       </a:r>
                     </a:p>
@@ -26960,7 +27005,7 @@
                     <a:lstStyle/>
                     <a:p>
                       <a:r>
-                        <a:rPr lang="en-CA" sz="1400" dirty="0"/>
+                        <a:rPr lang="en-CA" sz="1400"/>
                         <a:t>Contact,…</a:t>
                       </a:r>
                     </a:p>
@@ -26973,7 +27018,7 @@
                     <a:lstStyle/>
                     <a:p>
                       <a:r>
-                        <a:rPr lang="en-CA" sz="1400" dirty="0"/>
+                        <a:rPr lang="en-CA" sz="1400"/>
                         <a:t>Euribor3m,…</a:t>
                       </a:r>
                     </a:p>
@@ -27015,7 +27060,7 @@
               <a:rPr lang="en-US" smtClean="0"/>
               <a:t>2</a:t>
             </a:fld>
-            <a:endParaRPr lang="en-US" dirty="0"/>
+            <a:endParaRPr lang="en-US"/>
           </a:p>
         </p:txBody>
       </p:sp>
@@ -27424,7 +27469,7 @@
               <a:rPr lang="en-US" smtClean="0"/>
               <a:t>3</a:t>
             </a:fld>
-            <a:endParaRPr lang="en-US" dirty="0"/>
+            <a:endParaRPr lang="en-US"/>
           </a:p>
         </p:txBody>
       </p:sp>
@@ -27512,7 +27557,7 @@
           </p:nvPr>
         </p:nvPicPr>
         <p:blipFill>
-          <a:blip r:embed="rId2">
+          <a:blip r:embed="rId3">
             <a:alphaModFix amt="10000"/>
             <a:extLst>
               <a:ext uri="{28A0092B-C50C-407E-A947-70E740481C1C}">
@@ -27558,7 +27603,7 @@
           </p:nvPr>
         </p:nvPicPr>
         <p:blipFill>
-          <a:blip r:embed="rId3">
+          <a:blip r:embed="rId4">
             <a:extLst>
               <a:ext uri="{28A0092B-C50C-407E-A947-70E740481C1C}">
                 <a14:useLocalDpi xmlns:a14="http://schemas.microsoft.com/office/drawing/2010/main" val="0"/>
@@ -27603,7 +27648,7 @@
           </p:nvPr>
         </p:nvPicPr>
         <p:blipFill>
-          <a:blip r:embed="rId4" cstate="print">
+          <a:blip r:embed="rId5" cstate="print">
             <a:extLst>
               <a:ext uri="{28A0092B-C50C-407E-A947-70E740481C1C}">
                 <a14:useLocalDpi xmlns:a14="http://schemas.microsoft.com/office/drawing/2010/main" val="0"/>
@@ -27832,7 +27877,7 @@
           </p:nvPr>
         </p:nvPicPr>
         <p:blipFill>
-          <a:blip r:embed="rId2">
+          <a:blip r:embed="rId3">
             <a:alphaModFix amt="10000"/>
             <a:extLst>
               <a:ext uri="{28A0092B-C50C-407E-A947-70E740481C1C}">
@@ -28032,7 +28077,7 @@
           </p:nvPr>
         </p:nvPicPr>
         <p:blipFill>
-          <a:blip r:embed="rId3">
+          <a:blip r:embed="rId4">
             <a:extLst>
               <a:ext uri="{28A0092B-C50C-407E-A947-70E740481C1C}">
                 <a14:useLocalDpi xmlns:a14="http://schemas.microsoft.com/office/drawing/2010/main" val="0"/>
@@ -28083,7 +28128,7 @@
               </a:spcAft>
             </a:pPr>
             <a:r>
-              <a:rPr lang="en-US" sz="1400" b="1" dirty="0"/>
+              <a:rPr lang="en-US" sz="1400" b="1"/>
               <a:t>Metrics: Accuracy, Recall (Subscribers), F1-score</a:t>
             </a:r>
           </a:p>
@@ -28104,15 +28149,15 @@
           <p:nvPr/>
         </p:nvPicPr>
         <p:blipFill>
-          <a:blip r:embed="rId5"/>
+          <a:blip r:embed="rId6"/>
           <a:stretch>
             <a:fillRect/>
           </a:stretch>
         </p:blipFill>
         <p:spPr>
           <a:xfrm>
-            <a:off x="3819161" y="3712352"/>
-            <a:ext cx="5212348" cy="2938817"/>
+            <a:off x="3819161" y="3645758"/>
+            <a:ext cx="5077877" cy="2423348"/>
           </a:xfrm>
           <a:prstGeom prst="rect">
             <a:avLst/>
@@ -28145,7 +28190,12 @@
             <p:ph type="sldNum" sz="quarter" idx="12"/>
           </p:nvPr>
         </p:nvSpPr>
-        <p:spPr/>
+        <p:spPr>
+          <a:xfrm>
+            <a:off x="7939369" y="6194145"/>
+            <a:ext cx="1157674" cy="597108"/>
+          </a:xfrm>
+        </p:spPr>
         <p:txBody>
           <a:bodyPr/>
           <a:lstStyle/>
@@ -28154,16 +28204,16 @@
               <a:rPr lang="en-US" smtClean="0"/>
               <a:t>4</a:t>
             </a:fld>
-            <a:endParaRPr lang="en-US" dirty="0"/>
+            <a:endParaRPr lang="en-US"/>
           </a:p>
         </p:txBody>
       </p:sp>
       <p:pic>
         <p:nvPicPr>
-          <p:cNvPr id="15" name="Picture 14">
+          <p:cNvPr id="6" name="Picture 5">
             <a:extLst>
               <a:ext uri="{FF2B5EF4-FFF2-40B4-BE49-F238E27FC236}">
-                <a16:creationId xmlns:a16="http://schemas.microsoft.com/office/drawing/2014/main" id="{F9021F0F-5A38-81A0-7F30-57D78DAB93AE}"/>
+                <a16:creationId xmlns:a16="http://schemas.microsoft.com/office/drawing/2014/main" id="{3CA0A2B2-547B-926D-EBCD-BFE6B3F6EEE9}"/>
               </a:ext>
             </a:extLst>
           </p:cNvPr>
@@ -28173,15 +28223,15 @@
           <p:nvPr/>
         </p:nvPicPr>
         <p:blipFill>
-          <a:blip r:embed="rId6"/>
+          <a:blip r:embed="rId7"/>
           <a:stretch>
             <a:fillRect/>
           </a:stretch>
         </p:blipFill>
         <p:spPr>
           <a:xfrm>
-            <a:off x="3833680" y="646036"/>
-            <a:ext cx="5212348" cy="2938818"/>
+            <a:off x="3821230" y="611867"/>
+            <a:ext cx="5076727" cy="2545952"/>
           </a:xfrm>
           <a:prstGeom prst="rect">
             <a:avLst/>
@@ -28762,7 +28812,7 @@
           <a:lstStyle/>
           <a:p>
             <a:r>
-              <a:rPr lang="en-US" dirty="0"/>
+              <a:rPr lang="en-US"/>
               <a:t>Feature Importance (SHAP Values)</a:t>
             </a:r>
           </a:p>
@@ -28915,7 +28965,7 @@
               <a:rPr lang="en-US" smtClean="0"/>
               <a:t>5</a:t>
             </a:fld>
-            <a:endParaRPr lang="en-US" dirty="0"/>
+            <a:endParaRPr lang="en-US"/>
           </a:p>
         </p:txBody>
       </p:sp>
@@ -29296,7 +29346,7 @@
           <a:lstStyle/>
           <a:p>
             <a:r>
-              <a:rPr lang="en-US" dirty="0"/>
+              <a:rPr lang="en-US"/>
               <a:t>Key Takeaways / Findings</a:t>
             </a:r>
           </a:p>
@@ -29364,7 +29414,7 @@
           <p:nvPr>
             <p:extLst>
               <p:ext uri="{D42A27DB-BD31-4B8C-83A1-F6EECF244321}">
-                <p14:modId xmlns:p14="http://schemas.microsoft.com/office/powerpoint/2010/main" val="1209278184"/>
+                <p14:modId xmlns:p14="http://schemas.microsoft.com/office/powerpoint/2010/main" val="822091910"/>
               </p:ext>
             </p:extLst>
           </p:nvPr>
@@ -29404,7 +29454,7 @@
               <a:rPr lang="en-US" smtClean="0"/>
               <a:t>6</a:t>
             </a:fld>
-            <a:endParaRPr lang="en-US" dirty="0"/>
+            <a:endParaRPr lang="en-US"/>
           </a:p>
         </p:txBody>
       </p:sp>

</xml_diff>